<commit_message>
Prompt-format fix: a trailing bare newline told the model to dedent
BPE fuses newline+indent into one token; prompts ending in a bare \n made
the model treat the function as complete (new def / eos). Removing one
character moved pass@10 from 0.0 to 0.4 for BOTH checkpoints. Task and app
prompts now end at the closing triple-quote. Deck + PDF updated with the
finding and HF links; n=10 rematch logged in results/ratchet_fixed_prompts.json.

Co-Authored-By: Claude Fable 5 <noreply@anthropic.com>
</commit_message>
<xml_diff>
--- a/slides/pygpt_slides.pptx
+++ b/slides/pygpt_slides.pptx
@@ -3871,7 +3871,7 @@
               </a:defRPr>
             </a:pPr>
             <a:r>
-              <a:t>Public repo: github.com/Rehan123-bash/pygpt  —  6 sanity checks gate every training run</a:t>
+              <a:t>Code: github.com/Rehan123-bash/pygpt  ·  Weights + runnable demo: huggingface.co/rehannn11223/pygpt</a:t>
             </a:r>
           </a:p>
         </p:txBody>
@@ -5883,7 +5883,7 @@
                         <a:defRPr sz="1200"/>
                       </a:pPr>
                       <a:r>
-                        <a:t>slide 11 + github.com/Rehan123-bash/pygpt ✓</a:t>
+                        <a:t>slide 11 + GitHub + hf.co/rehannn11223/pygpt ✓</a:t>
                       </a:r>
                     </a:p>
                   </a:txBody>
@@ -6522,7 +6522,7 @@
         </p:nvGraphicFramePr>
         <p:xfrm>
           <a:off x="457200" y="1371600"/>
-          <a:ext cx="11247120" cy="3291840"/>
+          <a:ext cx="11247120" cy="3657600"/>
         </p:xfrm>
         <a:graphic>
           <a:graphicData uri="http://schemas.openxmlformats.org/drawingml/2006/table">
@@ -6952,6 +6952,53 @@
                       </a:pPr>
                       <a:r>
                         <a:t>fp16 spikes; Kaggle 12 h session cap</a:t>
+                      </a:r>
+                    </a:p>
+                  </a:txBody>
+                  <a:tcPr/>
+                </a:tc>
+              </a:tr>
+              <a:tr h="365760">
+                <a:tc>
+                  <a:txBody>
+                    <a:bodyPr/>
+                    <a:lstStyle/>
+                    <a:p>
+                      <a:pPr>
+                        <a:defRPr sz="1200"/>
+                      </a:pPr>
+                      <a:r>
+                        <a:t>Prompt format</a:t>
+                      </a:r>
+                    </a:p>
+                  </a:txBody>
+                  <a:tcPr/>
+                </a:tc>
+                <a:tc>
+                  <a:txBody>
+                    <a:bodyPr/>
+                    <a:lstStyle/>
+                    <a:p>
+                      <a:pPr>
+                        <a:defRPr sz="1200"/>
+                      </a:pPr>
+                      <a:r>
+                        <a:t>prompts end at the closing """ — no trailing newline</a:t>
+                      </a:r>
+                    </a:p>
+                  </a:txBody>
+                  <a:tcPr/>
+                </a:tc>
+                <a:tc>
+                  <a:txBody>
+                    <a:bodyPr/>
+                    <a:lstStyle/>
+                    <a:p>
+                      <a:pPr>
+                        <a:defRPr sz="1200"/>
+                      </a:pPr>
+                      <a:r>
+                        <a:t>newline+indent is ONE BPE token; a bare \n says “dedent next” and the model closes the function. Removing one character: pass@10 went 0 → 0.4</a:t>
                       </a:r>
                     </a:p>
                   </a:txBody>

</xml_diff>

<commit_message>
Ship step-12900 model: official eval, three-stage results on slides, HF updated
- metrics.json: ppl 6.19 / AST 57% vs GPT-2 7% / pass@10 0.4 (n=10 official,
  0.58 at n=30); epoch-1 eval archived as metrics_epoch1.json
- Slides: pass@10 journey 0.00 -> 0.39 (newline fix) -> 0.58 (curriculum),
  specialization tax on limitations; PDF re-exported
- app/HF weights promoted; val_loss metadata = 1.8227 (held-out Python)

Co-Authored-By: Claude Fable 5 <noreply@anthropic.com>
</commit_message>
<xml_diff>
--- a/slides/pygpt_slides.pptx
+++ b/slides/pygpt_slides.pptx
@@ -4034,6 +4034,21 @@
               </a:defRPr>
             </a:pPr>
             <a:r>
+              <a:t>•  Specialization tax: the DSA curriculum cost +0.18 nats of general-Python loss — narrow gains aren't free</a:t>
+            </a:r>
+          </a:p>
+          <a:p>
+            <a:pPr>
+              <a:spcAft>
+                <a:spcPts val="1000"/>
+              </a:spcAft>
+              <a:defRPr sz="1800">
+                <a:solidFill>
+                  <a:srgbClr val="1A1A2E"/>
+                </a:solidFill>
+              </a:defRPr>
+            </a:pPr>
+            <a:r>
               <a:t>•  Future work:</a:t>
             </a:r>
           </a:p>
@@ -5347,7 +5362,7 @@
               </a:defRPr>
             </a:pPr>
             <a:r>
-              <a:t>–  Kaggle: 30 GPU-h/week free — total project spend 7.3 h, leaving 22.7 h reserve</a:t>
+              <a:t>–  Kaggle: 30 GPU-h/week free — 16.5 h spent incl. a 2nd epoch and a DSA curriculum phase; 13.5 h reserve never needed</a:t>
             </a:r>
           </a:p>
           <a:p>
@@ -5697,7 +5712,7 @@
                         <a:defRPr sz="1200"/>
                       </a:pPr>
                       <a:r>
-                        <a:t>1.685 in 6.75 h ✓ (ppl 5.24)</a:t>
+                        <a:t>1.639 after 2 epochs ✓ · shipped DSA-specialized model: 1.82 (slide 9)</a:t>
                       </a:r>
                     </a:p>
                   </a:txBody>
@@ -5759,7 +5774,7 @@
                         <a:defRPr sz="1200"/>
                       </a:pPr>
                       <a:r>
-                        <a:t>59% AST-valid vs GPT-2 10% ✓ · pass@10 = 0 (honest)</a:t>
+                        <a:t>AST-valid 57% vs GPT-2 7% ✓ · DSA pass@10 0.58 vs GPT-2 0.00 ✓</a:t>
                       </a:r>
                     </a:p>
                   </a:txBody>
@@ -7194,7 +7209,7 @@
                         <a:defRPr sz="1300"/>
                       </a:pPr>
                       <a:r>
-                        <a:t>Val perplexity</a:t>
+                        <a:t>Val perplexity (Python)</a:t>
                       </a:r>
                     </a:p>
                   </a:txBody>
@@ -7224,7 +7239,7 @@
                         <a:defRPr sz="1300"/>
                       </a:pPr>
                       <a:r>
-                        <a:t>n/a (different vocab)</a:t>
+                        <a:t>n/a (other vocab)</a:t>
                       </a:r>
                     </a:p>
                   </a:txBody>
@@ -7239,7 +7254,7 @@
                         <a:defRPr sz="1300"/>
                       </a:pPr>
                       <a:r>
-                        <a:t>5.24</a:t>
+                        <a:t>6.19 (5.24 @ 1 epoch)</a:t>
                       </a:r>
                     </a:p>
                   </a:txBody>
@@ -7286,7 +7301,7 @@
                         <a:defRPr sz="1300"/>
                       </a:pPr>
                       <a:r>
-                        <a:t>10%</a:t>
+                        <a:t>7%</a:t>
                       </a:r>
                     </a:p>
                   </a:txBody>
@@ -7301,7 +7316,7 @@
                         <a:defRPr sz="1300"/>
                       </a:pPr>
                       <a:r>
-                        <a:t>59%</a:t>
+                        <a:t>57%</a:t>
                       </a:r>
                     </a:p>
                   </a:txBody>
@@ -7318,7 +7333,7 @@
                         <a:defRPr sz="1300"/>
                       </a:pPr>
                       <a:r>
-                        <a:t>pass@1 (5 tasks)</a:t>
+                        <a:t>pass@1 (5 DSA tasks)</a:t>
                       </a:r>
                     </a:p>
                   </a:txBody>
@@ -7348,7 +7363,7 @@
                         <a:defRPr sz="1300"/>
                       </a:pPr>
                       <a:r>
-                        <a:t>0</a:t>
+                        <a:t>0.00</a:t>
                       </a:r>
                     </a:p>
                   </a:txBody>
@@ -7363,7 +7378,7 @@
                         <a:defRPr sz="1300"/>
                       </a:pPr>
                       <a:r>
-                        <a:t>0</a:t>
+                        <a:t>0.09</a:t>
                       </a:r>
                     </a:p>
                   </a:txBody>
@@ -7380,7 +7395,7 @@
                         <a:defRPr sz="1300"/>
                       </a:pPr>
                       <a:r>
-                        <a:t>pass@10 (5 tasks)</a:t>
+                        <a:t>pass@10 (5 DSA tasks)</a:t>
                       </a:r>
                     </a:p>
                   </a:txBody>
@@ -7410,7 +7425,7 @@
                         <a:defRPr sz="1300"/>
                       </a:pPr>
                       <a:r>
-                        <a:t>0</a:t>
+                        <a:t>0.00</a:t>
                       </a:r>
                     </a:p>
                   </a:txBody>
@@ -7425,7 +7440,7 @@
                         <a:defRPr sz="1300"/>
                       </a:pPr>
                       <a:r>
-                        <a:t>0</a:t>
+                        <a:t>0.58</a:t>
                       </a:r>
                     </a:p>
                   </a:txBody>
@@ -7469,7 +7484,7 @@
               </a:defRPr>
             </a:pPr>
             <a:r>
-              <a:t>Loss 10.4 → 1.685 over one epoch (6.75 h).</a:t>
+              <a:t>Loss 10.4 → 1.639 over two epochs; a final DSA curriculum phase trades +0.18 nats of general loss for 1.5× the functional pass rate — specialization, measured.</a:t>
             </a:r>
           </a:p>
           <a:p>
@@ -7484,7 +7499,7 @@
               </a:defRPr>
             </a:pPr>
             <a:r>
-              <a:t>59% of completions parse as Python — 6× vanilla GPT-2. But 0/5 toy tasks pass hidden tests: 7 GPU-hours buys plausible, not correct. CodeParrot used 50–100× more compute.</a:t>
+              <a:t>pass@10 journey: 0.00 → 0.39 by removing ONE character from the prompt (the newline/BPE finding, slide 8) → 0.58 with the curriculum. GPT-2 stays at 0.00 throughout.</a:t>
             </a:r>
           </a:p>
           <a:p>
@@ -7499,7 +7514,7 @@
               </a:defRPr>
             </a:pPr>
             <a:r>
-              <a:t>Best sample: read_json → idiomatic `with open(path) as f: return json.load(f)` — one missing import from passing.</a:t>
+              <a:t>is_prime: 0 passes for every model — the honest boundary of 110M params at this budget.</a:t>
             </a:r>
           </a:p>
         </p:txBody>

</xml_diff>

<commit_message>
Ship run-2 model (step 17750): ppl 4.52, AST 60%, pass@10 0.80
Official eval + n=30 ratchet (0.60/0.80 vs champion 0.087/0.58). Slides,
PDF, loss curve (full 2.33B-token run), results/, HF card all updated.

Co-Authored-By: Claude Fable 5 <noreply@anthropic.com>
</commit_message>
<xml_diff>
--- a/slides/pygpt_slides.pptx
+++ b/slides/pygpt_slides.pptx
@@ -5362,7 +5362,7 @@
               </a:defRPr>
             </a:pPr>
             <a:r>
-              <a:t>–  Kaggle: 30 GPU-h/week free — 16.5 h spent incl. a 2nd epoch and a DSA curriculum phase; 13.5 h reserve never needed</a:t>
+              <a:t>–  Kaggle: 30 GPU-h/week free — final 2.35B-token run took 17.5 h across two resumed sessions, inside one weekly quota</a:t>
             </a:r>
           </a:p>
           <a:p>
@@ -5712,7 +5712,7 @@
                         <a:defRPr sz="1200"/>
                       </a:pPr>
                       <a:r>
-                        <a:t>1.639 after 2 epochs ✓ · shipped DSA-specialized model: 1.82 (slide 9)</a:t>
+                        <a:t>1.509 — 2.35B fresh tokens, ≈Chinchilla-optimal ✓ (ppl 4.52)</a:t>
                       </a:r>
                     </a:p>
                   </a:txBody>
@@ -5774,7 +5774,7 @@
                         <a:defRPr sz="1200"/>
                       </a:pPr>
                       <a:r>
-                        <a:t>AST-valid 57% vs GPT-2 7% ✓ · DSA pass@10 0.58 vs GPT-2 0.00 ✓</a:t>
+                        <a:t>AST-valid 60% vs GPT-2 7% ✓ · DSA pass@10 0.80 vs GPT-2 0.00 ✓</a:t>
                       </a:r>
                     </a:p>
                   </a:txBody>
@@ -7254,7 +7254,7 @@
                         <a:defRPr sz="1300"/>
                       </a:pPr>
                       <a:r>
-                        <a:t>6.19 (5.24 @ 1 epoch)</a:t>
+                        <a:t>4.52</a:t>
                       </a:r>
                     </a:p>
                   </a:txBody>
@@ -7316,7 +7316,7 @@
                         <a:defRPr sz="1300"/>
                       </a:pPr>
                       <a:r>
-                        <a:t>57%</a:t>
+                        <a:t>60%</a:t>
                       </a:r>
                     </a:p>
                   </a:txBody>
@@ -7378,7 +7378,7 @@
                         <a:defRPr sz="1300"/>
                       </a:pPr>
                       <a:r>
-                        <a:t>0.09</a:t>
+                        <a:t>0.60</a:t>
                       </a:r>
                     </a:p>
                   </a:txBody>
@@ -7440,7 +7440,7 @@
                         <a:defRPr sz="1300"/>
                       </a:pPr>
                       <a:r>
-                        <a:t>0.58</a:t>
+                        <a:t>0.80</a:t>
                       </a:r>
                     </a:p>
                   </a:txBody>
@@ -7484,7 +7484,7 @@
               </a:defRPr>
             </a:pPr>
             <a:r>
-              <a:t>Loss 10.4 → 1.639 over two epochs; a final DSA curriculum phase trades +0.18 nats of general loss for 1.5× the functional pass rate — specialization, measured.</a:t>
+              <a:t>Final run: 10.4 → 1.509 over 2.35B fresh tokens (≈Chinchilla-optimal) with the DSA curriculum blended at 6.6% — no specialization tax this time; one LR schedule across two sessions (dashed line = tested resume).</a:t>
             </a:r>
           </a:p>
           <a:p>
@@ -7499,7 +7499,7 @@
               </a:defRPr>
             </a:pPr>
             <a:r>
-              <a:t>pass@10 journey: 0.00 → 0.39 by removing ONE character from the prompt (the newline/BPE finding, slide 8) → 0.58 with the curriculum. GPT-2 stays at 0.00 throughout.</a:t>
+              <a:t>pass@10 journey: 0.00 → 0.39 (removing ONE prompt character — the newline/BPE finding, slide 8) → 0.58 (bolt-on curriculum) → 0.80 (fresh data + blend). GPT-2: 0.00 throughout. add: 30/30, divide: 29/30 at n=30.</a:t>
             </a:r>
           </a:p>
           <a:p>

</xml_diff>